<commit_message>
Fotos reais no lugar das geradas, texto dela na home e nenhum travessão
As treze fotos que ela mandou entram no lugar das três imagens de IA, que
ficam guardadas em assets/img/_ia e saem de todas as páginas. O hero passa
a ser a sala com as duas macas, e o retrato é o que ela escolheu.

Cada foto ganhou o recorte da caixa em que aparece, inclusive um recorte em
pé para as telas cheias no celular: o pior fator de ampliação do site cai
para 1,3 vez em densidade 3, contra as 5,3 vezes da versão com IA.

A home recebe o texto de apresentação que ela escreveu, com os 8 anos de
estética e a formação em Biomedicina Estética, que corrige o BioMED que eu
havia deduzido. Entra também a galeria do espaço.

Nenhum travessão sobrou em nenhuma página, no catálogo nem na apresentação.
O véu do hero foi recalibrado: a sala é branca e o véu antigo, feito para
foto escura, apagava a foto.
</commit_message>
<xml_diff>
--- a/apresentacao-cintia-godoy.pptx
+++ b/apresentacao-cintia-godoy.pptx
@@ -1679,7 +1679,7 @@
                 <a:ea typeface="Calibri" pitchFamily="34" charset="-122"/>
                 <a:cs typeface="Calibri" pitchFamily="34" charset="-120"/>
               </a:rPr>
-              <a:t>Cíntia Godoy — Estética &amp; Bem-Estar</a:t>
+              <a:t>Cíntia Godoy Estética e Bem-Estar</a:t>
             </a:r>
             <a:endParaRPr lang="en-US" sz="1300" dirty="0"/>
           </a:p>
@@ -1990,7 +1990,7 @@
                 <a:ea typeface="Calibri" pitchFamily="34" charset="-122"/>
                 <a:cs typeface="Calibri" pitchFamily="34" charset="-120"/>
               </a:rPr>
-              <a:t>Jornada sentada, celular na mão, reunião atrás de reunião. O corpo cobra no meio do dia — e quase nunca existe um lugar para resolver isso sem sair do trabalho.</a:t>
+              <a:t>Jornada sentada, celular na mão, reunião atrás de reunião. O corpo cobra no meio do dia, e quase nunca existe um lugar para resolver isso sem sair do trabalho.</a:t>
             </a:r>
             <a:endParaRPr lang="en-US" sz="1400" dirty="0"/>
           </a:p>
@@ -2019,7 +2019,7 @@
                 <a:ea typeface="Calibri" pitchFamily="34" charset="-122"/>
                 <a:cs typeface="Calibri" pitchFamily="34" charset="-120"/>
               </a:rPr>
-              <a:t>Cíntia Godoy atende há anos em Mogi Mirim, na Avenida Santo Antônio, 127. Faz o atendimento no espaço dela, com hora marcada, e leva a cadeira de quick massage até empresas, escolas e eventos da região.</a:t>
+              <a:t>Cíntia Godoy atua na estética há 8 anos e atende em Mogi Mirim, na Avenida Santo Antônio, 127. Faz o atendimento no espaço dela, com hora marcada, e leva a cadeira de quick massage até empresas, escolas e eventos da região.</a:t>
             </a:r>
             <a:endParaRPr lang="en-US" sz="1400" dirty="0"/>
           </a:p>
@@ -2027,7 +2027,7 @@
       </p:sp>
       <p:pic>
         <p:nvPicPr>
-          <p:cNvPr id="5" name="Image 0" descr="/Users/lopes/sites/cintia-godoy/assets/img/massagem.jpg">    </p:cNvPr>
+          <p:cNvPr id="5" name="Image 0" descr="/Users/lopes/sites/cintia-godoy/assets/img/serv-headspa.jpg">    </p:cNvPr>
           <p:cNvPicPr>
             <a:picLocks noChangeAspect="1"/>
           </p:cNvPicPr>
@@ -2256,7 +2256,7 @@
                 <a:ea typeface="Calibri" pitchFamily="34" charset="-122"/>
                 <a:cs typeface="Calibri" pitchFamily="34" charset="-120"/>
               </a:rPr>
-              <a:t>Lipedema e taping — Bioage, Rio Claro</a:t>
+              <a:t>Lipedema e taping na Bioage de Rio Claro</a:t>
             </a:r>
             <a:endParaRPr lang="en-US" sz="1400" dirty="0"/>
           </a:p>
@@ -2399,7 +2399,7 @@
                 <a:ea typeface="Calibri" pitchFamily="34" charset="-122"/>
                 <a:cs typeface="Calibri" pitchFamily="34" charset="-120"/>
               </a:rPr>
-              <a:t>BioMED — em formação</a:t>
+              <a:t>Biomedicina Estética, em conclusão</a:t>
             </a:r>
             <a:endParaRPr lang="en-US" sz="1400" dirty="0"/>
           </a:p>
@@ -2441,7 +2441,7 @@
                 <a:ea typeface="Calibri" pitchFamily="34" charset="-122"/>
                 <a:cs typeface="Calibri" pitchFamily="34" charset="-120"/>
               </a:rPr>
-              <a:t>Formação em andamento, que sustenta a leitura do que cada pele e cada corpo pedem antes de escolher o protocolo.</a:t>
+              <a:t>Técnica em Estética, concluindo a formação em Biomedicina Estética. É o que sustenta a leitura do que cada pele e cada corpo pedem.</a:t>
             </a:r>
             <a:endParaRPr lang="en-US" sz="1250" dirty="0"/>
           </a:p>
@@ -2779,7 +2779,7 @@
                 <a:ea typeface="Calibri" pitchFamily="34" charset="-122"/>
                 <a:cs typeface="Calibri" pitchFamily="34" charset="-120"/>
               </a:rPr>
-              <a:t>Drenagem linfática relaxante — o carro-chefe</a:t>
+              <a:t>Drenagem linfática relaxante, o carro-chefe</a:t>
             </a:r>
             <a:endParaRPr lang="en-US" sz="1350" dirty="0"/>
           </a:p>
@@ -2800,7 +2800,7 @@
                 <a:ea typeface="Calibri" pitchFamily="34" charset="-122"/>
                 <a:cs typeface="Calibri" pitchFamily="34" charset="-120"/>
               </a:rPr>
-              <a:t>Head spa — cabeça e couro cabeludo</a:t>
+              <a:t>Head spa, cabeça e couro cabeludo</a:t>
             </a:r>
             <a:endParaRPr lang="en-US" sz="1350" dirty="0"/>
           </a:p>
@@ -2821,7 +2821,7 @@
                 <a:ea typeface="Calibri" pitchFamily="34" charset="-122"/>
                 <a:cs typeface="Calibri" pitchFamily="34" charset="-120"/>
               </a:rPr>
-              <a:t>Limpeza de pele biofotônica — RenoveSSe Skin Glow</a:t>
+              <a:t>Limpeza de pele biofotônica, RenoveSSe Skin Glow</a:t>
             </a:r>
             <a:endParaRPr lang="en-US" sz="1350" dirty="0"/>
           </a:p>
@@ -2842,7 +2842,7 @@
                 <a:ea typeface="Calibri" pitchFamily="34" charset="-122"/>
                 <a:cs typeface="Calibri" pitchFamily="34" charset="-120"/>
               </a:rPr>
-              <a:t>Depilação a laser — equipamento Acrus</a:t>
+              <a:t>Depilação a laser, equipamento Acrus</a:t>
             </a:r>
             <a:endParaRPr lang="en-US" sz="1350" dirty="0"/>
           </a:p>
@@ -3466,7 +3466,7 @@
                 <a:ea typeface="Calibri" pitchFamily="34" charset="-122"/>
                 <a:cs typeface="Calibri" pitchFamily="34" charset="-120"/>
               </a:rPr>
-              <a:t>A duração de cada atendimento e quantas pessoas cabem no período — combinado antes, nunca no dia.</a:t>
+              <a:t>A duração de cada atendimento e quantas pessoas cabem no período. Combinado antes, nunca no dia.</a:t>
             </a:r>
             <a:endParaRPr lang="en-US" sz="1250" dirty="0"/>
           </a:p>
@@ -3702,7 +3702,7 @@
                 <a:ea typeface="Calibri" pitchFamily="34" charset="-122"/>
                 <a:cs typeface="Calibri" pitchFamily="34" charset="-120"/>
               </a:rPr>
-              <a:t>A semana de prevenção precisa de uma atração que as pessoas queiram fazer — e que fale de saúde sem palestra.</a:t>
+              <a:t>A semana de prevenção precisa de uma atração que as pessoas queiram fazer, e que fale de saúde sem palestra.</a:t>
             </a:r>
             <a:endParaRPr lang="en-US" sz="1250" dirty="0"/>
           </a:p>
@@ -3948,7 +3948,7 @@
                 <a:ea typeface="Calibri" pitchFamily="34" charset="-122"/>
                 <a:cs typeface="Calibri" pitchFamily="34" charset="-120"/>
               </a:rPr>
-              <a:t>No estande, a cadeira vira ponto de parada — e motivo para a pessoa voltar.</a:t>
+              <a:t>No estande, a cadeira vira ponto de parada, e motivo para a pessoa voltar.</a:t>
             </a:r>
             <a:endParaRPr lang="en-US" sz="1250" dirty="0"/>
           </a:p>
@@ -4142,7 +4142,7 @@
                 <a:ea typeface="Calibri" pitchFamily="34" charset="-122"/>
                 <a:cs typeface="Calibri" pitchFamily="34" charset="-120"/>
               </a:rPr>
-              <a:t>pessoas em um único dia — o convite veio de uma escola de Mogi Mirim, em setembro de 2026.</a:t>
+              <a:t>pessoas em um único dia. O convite veio de uma escola de Mogi Mirim, em setembro de 2026.</a:t>
             </a:r>
             <a:endParaRPr lang="en-US" sz="1300" dirty="0"/>
           </a:p>
@@ -4213,7 +4213,7 @@
                 <a:ea typeface="Calibri" pitchFamily="34" charset="-122"/>
                 <a:cs typeface="Calibri" pitchFamily="34" charset="-120"/>
               </a:rPr>
-              <a:t>Mais de 4.700 pessoas acompanham o trabalho no Instagram @cintiagodoyestetica — é de lá e do Google que chega a maior parte de quem procura.</a:t>
+              <a:t>Mais de 4.700 pessoas acompanham o trabalho no Instagram @cintiagodoyestetica. É de lá e do Google que chega a maior parte de quem procura.</a:t>
             </a:r>
             <a:endParaRPr lang="en-US" sz="1350" dirty="0"/>
           </a:p>
@@ -4889,7 +4889,7 @@
                 <a:ea typeface="Calibri" pitchFamily="34" charset="-122"/>
                 <a:cs typeface="Calibri" pitchFamily="34" charset="-120"/>
               </a:rPr>
-              <a:t>Av. Santo Antônio, 127 — Centro, Mogi Mirim, SP</a:t>
+              <a:t>Av. Santo Antônio, 127, Centro, Mogi Mirim, SP</a:t>
             </a:r>
             <a:endParaRPr lang="en-US" sz="1300" dirty="0"/>
           </a:p>

</xml_diff>